<commit_message>
Add desktop collapsible Filters/Tools, in-app guide link, and FAQ on shared-folder status conflicts
- Remove desktop override that forced Filters/Tools sections expanded, so they collapse like on mobile
- Add Quick Start Guide download link to the in-app help modal
- Add FAQ entry (deck + guide) explaining that existing place status wins over imports from shared folders
- Add QR code to closing slide and reframe Booking.com FAQ as a future affiliate opportunity
</commit_message>
<xml_diff>
--- a/Visual Materials/My projects/AI/Gemenai project/better version cloude/MapFolio-DemoDay.pptx
+++ b/Visual Materials/My projects/AI/Gemenai project/better version cloude/MapFolio-DemoDay.pptx
@@ -15,9 +15,10 @@
     <p:sldId id="263" r:id="rId9"/>
     <p:sldId id="264" r:id="rId10"/>
     <p:sldId id="265" r:id="rId11"/>
+    <p:sldId id="266" r:id="rId12"/>
   </p:sldIdLst>
   <p:notesMasterIdLst>
-    <p:notesMasterId r:id="rId12"/>
+    <p:notesMasterId r:id="rId13"/>
   </p:notesMasterIdLst>
   <p:sldSz cx="12192000" cy="6858000"/>
   <p:notesSz cx="6858000" cy="12192000"/>
@@ -623,6 +624,94 @@
             <a:fld id="{F7021451-1387-4CA6-816F-3879F97B5CBC}" type="slidenum">
               <a:rPr lang="en-US"/>
               <a:t>10</a:t>
+            </a:fld>
+            <a:endParaRPr lang="en-US"/>
+          </a:p>
+        </p:txBody>
+      </p:sp>
+    </p:spTree>
+    <p:extLst>
+      <p:ext uri="{BB962C8B-B14F-4D97-AF65-F5344CB8AC3E}">
+        <p14:creationId xmlns:p14="http://schemas.microsoft.com/office/powerpoint/2010/main" val="1024086991"/>
+      </p:ext>
+    </p:extLst>
+  </p:cSld>
+  <p:clrMapOvr>
+    <a:masterClrMapping/>
+  </p:clrMapOvr>
+</p:notes>
+</file>
+
+<file path=ppt/notesSlides/notesSlide11.xml><?xml version="1.0" encoding="utf-8"?>
+<p:notes xmlns:a="http://schemas.openxmlformats.org/drawingml/2006/main" xmlns:r="http://schemas.openxmlformats.org/officeDocument/2006/relationships" xmlns:p="http://schemas.openxmlformats.org/presentationml/2006/main">
+  <p:cSld>
+    <p:spTree>
+      <p:nvGrpSpPr>
+        <p:cNvPr id="1" name=""/>
+        <p:cNvGrpSpPr/>
+        <p:nvPr/>
+      </p:nvGrpSpPr>
+      <p:grpSpPr>
+        <a:xfrm>
+          <a:off x="0" y="0"/>
+          <a:ext cx="0" cy="0"/>
+          <a:chOff x="0" y="0"/>
+          <a:chExt cx="0" cy="0"/>
+        </a:xfrm>
+      </p:grpSpPr>
+      <p:sp>
+        <p:nvSpPr>
+          <p:cNvPr id="2" name="Slide Image Placeholder 1"/>
+          <p:cNvSpPr>
+            <a:spLocks noGrp="1" noRot="1" noChangeAspect="1"/>
+          </p:cNvSpPr>
+          <p:nvPr>
+            <p:ph type="sldImg"/>
+          </p:nvPr>
+        </p:nvSpPr>
+        <p:spPr/>
+      </p:sp>
+      <p:sp>
+        <p:nvSpPr>
+          <p:cNvPr id="3" name="Notes Placeholder 2"/>
+          <p:cNvSpPr>
+            <a:spLocks noGrp="1"/>
+          </p:cNvSpPr>
+          <p:nvPr>
+            <p:ph type="body" idx="1"/>
+          </p:nvPr>
+        </p:nvSpPr>
+        <p:spPr/>
+        <p:txBody>
+          <a:bodyPr/>
+          <a:lstStyle/>
+          <a:p>
+            <a:r>
+              <a:rPr lang="en-US" dirty="0"/>
+              <a:t/>
+            </a:r>
+            <a:endParaRPr lang="en-US" dirty="0"/>
+          </a:p>
+        </p:txBody>
+      </p:sp>
+      <p:sp>
+        <p:nvSpPr>
+          <p:cNvPr id="4" name="Slide Number Placeholder 3"/>
+          <p:cNvSpPr>
+            <a:spLocks noGrp="1"/>
+          </p:cNvSpPr>
+          <p:nvPr>
+            <p:ph type="sldNum" sz="quarter" idx="10"/>
+          </p:nvPr>
+        </p:nvSpPr>
+        <p:spPr/>
+        <p:txBody>
+          <a:bodyPr/>
+          <a:lstStyle/>
+          <a:p>
+            <a:fld id="{F7021451-1387-4CA6-816F-3879F97B5CBC}" type="slidenum">
+              <a:rPr lang="en-US"/>
+              <a:t>11</a:t>
             </a:fld>
             <a:endParaRPr lang="en-US"/>
           </a:p>
@@ -1887,6 +1976,628 @@
     <p:bg>
       <p:bgPr>
         <a:solidFill>
+          <a:srgbClr val="FFFFFF"/>
+        </a:solidFill>
+      </p:bgPr>
+    </p:bg>
+    <p:spTree>
+      <p:nvGrpSpPr>
+        <p:cNvPr id="1" name=""/>
+        <p:cNvGrpSpPr/>
+        <p:nvPr/>
+      </p:nvGrpSpPr>
+      <p:grpSpPr>
+        <a:xfrm>
+          <a:off x="0" y="0"/>
+          <a:ext cx="0" cy="0"/>
+          <a:chOff x="0" y="0"/>
+          <a:chExt cx="0" cy="0"/>
+        </a:xfrm>
+      </p:grpSpPr>
+      <p:sp>
+        <p:nvSpPr>
+          <p:cNvPr id="2" name="Text 0"/>
+          <p:cNvSpPr/>
+          <p:nvPr/>
+        </p:nvSpPr>
+        <p:spPr>
+          <a:xfrm>
+            <a:off x="548640" y="457200"/>
+            <a:ext cx="10972800" cy="731520"/>
+          </a:xfrm>
+          <a:prstGeom prst="rect">
+            <a:avLst/>
+          </a:prstGeom>
+          <a:noFill/>
+          <a:ln/>
+        </p:spPr>
+        <p:txBody>
+          <a:bodyPr wrap="square" lIns="0" tIns="0" rIns="0" bIns="0" rtlCol="0" anchor="ctr"/>
+          <a:lstStyle/>
+          <a:p>
+            <a:pPr indent="0" marL="0">
+              <a:buNone/>
+            </a:pPr>
+            <a:r>
+              <a:rPr lang="en-US" sz="3200" b="1" dirty="0">
+                <a:solidFill>
+                  <a:srgbClr val="14213D"/>
+                </a:solidFill>
+                <a:latin typeface="Trebuchet MS" pitchFamily="34" charset="0"/>
+                <a:ea typeface="Trebuchet MS" pitchFamily="34" charset="-122"/>
+                <a:cs typeface="Trebuchet MS" pitchFamily="34" charset="-120"/>
+              </a:rPr>
+              <a:t>What's next: an idea worth exploring</a:t>
+            </a:r>
+            <a:endParaRPr lang="en-US" sz="3200" dirty="0"/>
+          </a:p>
+        </p:txBody>
+      </p:sp>
+      <p:sp>
+        <p:nvSpPr>
+          <p:cNvPr id="3" name="Shape 1"/>
+          <p:cNvSpPr/>
+          <p:nvPr/>
+        </p:nvSpPr>
+        <p:spPr>
+          <a:xfrm>
+            <a:off x="548640" y="1371600"/>
+            <a:ext cx="11064240" cy="1234440"/>
+          </a:xfrm>
+          <a:prstGeom prst="rect">
+            <a:avLst/>
+          </a:prstGeom>
+          <a:solidFill>
+            <a:srgbClr val="F4F6F8"/>
+          </a:solidFill>
+          <a:ln/>
+        </p:spPr>
+      </p:sp>
+      <p:sp>
+        <p:nvSpPr>
+          <p:cNvPr id="4" name="Text 2"/>
+          <p:cNvSpPr/>
+          <p:nvPr/>
+        </p:nvSpPr>
+        <p:spPr>
+          <a:xfrm>
+            <a:off x="822960" y="1508760"/>
+            <a:ext cx="10515600" cy="457200"/>
+          </a:xfrm>
+          <a:prstGeom prst="rect">
+            <a:avLst/>
+          </a:prstGeom>
+          <a:noFill/>
+          <a:ln/>
+        </p:spPr>
+        <p:txBody>
+          <a:bodyPr wrap="square" lIns="0" tIns="0" rIns="0" bIns="0" rtlCol="0" anchor="ctr"/>
+          <a:lstStyle/>
+          <a:p>
+            <a:pPr indent="0" marL="0">
+              <a:buNone/>
+            </a:pPr>
+            <a:r>
+              <a:rPr lang="en-US" sz="1800" b="1" dirty="0">
+                <a:solidFill>
+                  <a:srgbClr val="1C7293"/>
+                </a:solidFill>
+                <a:latin typeface="Trebuchet MS" pitchFamily="34" charset="0"/>
+                <a:ea typeface="Trebuchet MS" pitchFamily="34" charset="-122"/>
+                <a:cs typeface="Trebuchet MS" pitchFamily="34" charset="-120"/>
+              </a:rPr>
+              <a:t>💡  Sell curated trip collections</a:t>
+            </a:r>
+            <a:endParaRPr lang="en-US" sz="1800" dirty="0"/>
+          </a:p>
+        </p:txBody>
+      </p:sp>
+      <p:sp>
+        <p:nvSpPr>
+          <p:cNvPr id="5" name="Text 3"/>
+          <p:cNvSpPr/>
+          <p:nvPr/>
+        </p:nvSpPr>
+        <p:spPr>
+          <a:xfrm>
+            <a:off x="822960" y="1920240"/>
+            <a:ext cx="10515600" cy="640080"/>
+          </a:xfrm>
+          <a:prstGeom prst="rect">
+            <a:avLst/>
+          </a:prstGeom>
+          <a:noFill/>
+          <a:ln/>
+        </p:spPr>
+        <p:txBody>
+          <a:bodyPr wrap="square" lIns="0" tIns="0" rIns="0" bIns="0" rtlCol="0" anchor="ctr"/>
+          <a:lstStyle/>
+          <a:p>
+            <a:pPr indent="0" marL="0">
+              <a:lnSpc>
+                <a:spcPct val="110000"/>
+              </a:lnSpc>
+              <a:buNone/>
+            </a:pPr>
+            <a:r>
+              <a:rPr lang="en-US" sz="1400" dirty="0">
+                <a:solidFill>
+                  <a:srgbClr val="1E1E1E"/>
+                </a:solidFill>
+                <a:latin typeface="Calibri" pitchFamily="34" charset="0"/>
+                <a:ea typeface="Calibri" pitchFamily="34" charset="-122"/>
+                <a:cs typeface="Calibri" pitchFamily="34" charset="-120"/>
+              </a:rPr>
+              <a:t>A folder of places + a trip-planner itinerary is basically a ready-made travel guide. People already pay for “where to eat in Lisbon” PDFs and curated maps — MapFolio could let creators package and sell their own collections.</a:t>
+            </a:r>
+            <a:endParaRPr lang="en-US" sz="1400" dirty="0"/>
+          </a:p>
+        </p:txBody>
+      </p:sp>
+      <p:sp>
+        <p:nvSpPr>
+          <p:cNvPr id="6" name="Shape 4"/>
+          <p:cNvSpPr/>
+          <p:nvPr/>
+        </p:nvSpPr>
+        <p:spPr>
+          <a:xfrm>
+            <a:off x="548640" y="2880360"/>
+            <a:ext cx="3611880" cy="3246120"/>
+          </a:xfrm>
+          <a:prstGeom prst="rect">
+            <a:avLst/>
+          </a:prstGeom>
+          <a:solidFill>
+            <a:srgbClr val="14213D"/>
+          </a:solidFill>
+          <a:ln/>
+        </p:spPr>
+      </p:sp>
+      <p:sp>
+        <p:nvSpPr>
+          <p:cNvPr id="7" name="Text 5"/>
+          <p:cNvSpPr/>
+          <p:nvPr/>
+        </p:nvSpPr>
+        <p:spPr>
+          <a:xfrm>
+            <a:off x="777240" y="3063240"/>
+            <a:ext cx="822960" cy="640080"/>
+          </a:xfrm>
+          <a:prstGeom prst="rect">
+            <a:avLst/>
+          </a:prstGeom>
+          <a:noFill/>
+          <a:ln/>
+        </p:spPr>
+        <p:txBody>
+          <a:bodyPr wrap="square" lIns="0" tIns="0" rIns="0" bIns="0" rtlCol="0" anchor="ctr"/>
+          <a:lstStyle/>
+          <a:p>
+            <a:pPr indent="0" marL="0">
+              <a:buNone/>
+            </a:pPr>
+            <a:r>
+              <a:rPr lang="en-US" sz="2800" dirty="0">
+                <a:solidFill>
+                  <a:srgbClr val="000000"/>
+                </a:solidFill>
+              </a:rPr>
+              <a:t>🗂️</a:t>
+            </a:r>
+            <a:endParaRPr lang="en-US" sz="2800" dirty="0"/>
+          </a:p>
+        </p:txBody>
+      </p:sp>
+      <p:sp>
+        <p:nvSpPr>
+          <p:cNvPr id="8" name="Text 6"/>
+          <p:cNvSpPr/>
+          <p:nvPr/>
+        </p:nvSpPr>
+        <p:spPr>
+          <a:xfrm>
+            <a:off x="777240" y="3703320"/>
+            <a:ext cx="3154680" cy="502920"/>
+          </a:xfrm>
+          <a:prstGeom prst="rect">
+            <a:avLst/>
+          </a:prstGeom>
+          <a:noFill/>
+          <a:ln/>
+        </p:spPr>
+        <p:txBody>
+          <a:bodyPr wrap="square" lIns="0" tIns="0" rIns="0" bIns="0" rtlCol="0" anchor="ctr"/>
+          <a:lstStyle/>
+          <a:p>
+            <a:pPr indent="0" marL="0">
+              <a:buNone/>
+            </a:pPr>
+            <a:r>
+              <a:rPr lang="en-US" sz="1600" b="1" dirty="0">
+                <a:solidFill>
+                  <a:srgbClr val="FFDE59"/>
+                </a:solidFill>
+                <a:latin typeface="Trebuchet MS" pitchFamily="34" charset="0"/>
+                <a:ea typeface="Trebuchet MS" pitchFamily="34" charset="-122"/>
+                <a:cs typeface="Trebuchet MS" pitchFamily="34" charset="-120"/>
+              </a:rPr>
+              <a:t>Premium folders</a:t>
+            </a:r>
+            <a:endParaRPr lang="en-US" sz="1600" dirty="0"/>
+          </a:p>
+        </p:txBody>
+      </p:sp>
+      <p:sp>
+        <p:nvSpPr>
+          <p:cNvPr id="9" name="Text 7"/>
+          <p:cNvSpPr/>
+          <p:nvPr/>
+        </p:nvSpPr>
+        <p:spPr>
+          <a:xfrm>
+            <a:off x="777240" y="4251960"/>
+            <a:ext cx="3154680" cy="1737360"/>
+          </a:xfrm>
+          <a:prstGeom prst="rect">
+            <a:avLst/>
+          </a:prstGeom>
+          <a:noFill/>
+          <a:ln/>
+        </p:spPr>
+        <p:txBody>
+          <a:bodyPr wrap="square" lIns="0" tIns="0" rIns="0" bIns="0" rtlCol="0" anchor="ctr"/>
+          <a:lstStyle/>
+          <a:p>
+            <a:pPr indent="0" marL="0">
+              <a:lnSpc>
+                <a:spcPct val="115000"/>
+              </a:lnSpc>
+              <a:buNone/>
+            </a:pPr>
+            <a:r>
+              <a:rPr lang="en-US" sz="1300" dirty="0">
+                <a:solidFill>
+                  <a:srgbClr val="E4E9EF"/>
+                </a:solidFill>
+                <a:latin typeface="Calibri" pitchFamily="34" charset="0"/>
+                <a:ea typeface="Calibri" pitchFamily="34" charset="-122"/>
+                <a:cs typeface="Calibri" pitchFamily="34" charset="-120"/>
+              </a:rPr>
+              <a:t>Creators (locals, frequent travellers, influencers) publish a folder as a paid “trip pack” — e.g. “3 days in Lisbon, foodie edition”.</a:t>
+            </a:r>
+            <a:endParaRPr lang="en-US" sz="1300" dirty="0"/>
+          </a:p>
+        </p:txBody>
+      </p:sp>
+      <p:sp>
+        <p:nvSpPr>
+          <p:cNvPr id="10" name="Shape 8"/>
+          <p:cNvSpPr/>
+          <p:nvPr/>
+        </p:nvSpPr>
+        <p:spPr>
+          <a:xfrm>
+            <a:off x="4434840" y="2880360"/>
+            <a:ext cx="3611880" cy="3246120"/>
+          </a:xfrm>
+          <a:prstGeom prst="rect">
+            <a:avLst/>
+          </a:prstGeom>
+          <a:solidFill>
+            <a:srgbClr val="14213D"/>
+          </a:solidFill>
+          <a:ln/>
+        </p:spPr>
+      </p:sp>
+      <p:sp>
+        <p:nvSpPr>
+          <p:cNvPr id="11" name="Text 9"/>
+          <p:cNvSpPr/>
+          <p:nvPr/>
+        </p:nvSpPr>
+        <p:spPr>
+          <a:xfrm>
+            <a:off x="4663440" y="3063240"/>
+            <a:ext cx="822960" cy="640080"/>
+          </a:xfrm>
+          <a:prstGeom prst="rect">
+            <a:avLst/>
+          </a:prstGeom>
+          <a:noFill/>
+          <a:ln/>
+        </p:spPr>
+        <p:txBody>
+          <a:bodyPr wrap="square" lIns="0" tIns="0" rIns="0" bIns="0" rtlCol="0" anchor="ctr"/>
+          <a:lstStyle/>
+          <a:p>
+            <a:pPr indent="0" marL="0">
+              <a:buNone/>
+            </a:pPr>
+            <a:r>
+              <a:rPr lang="en-US" sz="2800" dirty="0">
+                <a:solidFill>
+                  <a:srgbClr val="000000"/>
+                </a:solidFill>
+              </a:rPr>
+              <a:t>🧭</a:t>
+            </a:r>
+            <a:endParaRPr lang="en-US" sz="2800" dirty="0"/>
+          </a:p>
+        </p:txBody>
+      </p:sp>
+      <p:sp>
+        <p:nvSpPr>
+          <p:cNvPr id="12" name="Text 10"/>
+          <p:cNvSpPr/>
+          <p:nvPr/>
+        </p:nvSpPr>
+        <p:spPr>
+          <a:xfrm>
+            <a:off x="4663440" y="3703320"/>
+            <a:ext cx="3154680" cy="502920"/>
+          </a:xfrm>
+          <a:prstGeom prst="rect">
+            <a:avLst/>
+          </a:prstGeom>
+          <a:noFill/>
+          <a:ln/>
+        </p:spPr>
+        <p:txBody>
+          <a:bodyPr wrap="square" lIns="0" tIns="0" rIns="0" bIns="0" rtlCol="0" anchor="ctr"/>
+          <a:lstStyle/>
+          <a:p>
+            <a:pPr indent="0" marL="0">
+              <a:buNone/>
+            </a:pPr>
+            <a:r>
+              <a:rPr lang="en-US" sz="1600" b="1" dirty="0">
+                <a:solidFill>
+                  <a:srgbClr val="FFDE59"/>
+                </a:solidFill>
+                <a:latin typeface="Trebuchet MS" pitchFamily="34" charset="0"/>
+                <a:ea typeface="Trebuchet MS" pitchFamily="34" charset="-122"/>
+                <a:cs typeface="Trebuchet MS" pitchFamily="34" charset="-120"/>
+              </a:rPr>
+              <a:t>Itinerary included</a:t>
+            </a:r>
+            <a:endParaRPr lang="en-US" sz="1600" dirty="0"/>
+          </a:p>
+        </p:txBody>
+      </p:sp>
+      <p:sp>
+        <p:nvSpPr>
+          <p:cNvPr id="13" name="Text 11"/>
+          <p:cNvSpPr/>
+          <p:nvPr/>
+        </p:nvSpPr>
+        <p:spPr>
+          <a:xfrm>
+            <a:off x="4663440" y="4251960"/>
+            <a:ext cx="3154680" cy="1737360"/>
+          </a:xfrm>
+          <a:prstGeom prst="rect">
+            <a:avLst/>
+          </a:prstGeom>
+          <a:noFill/>
+          <a:ln/>
+        </p:spPr>
+        <p:txBody>
+          <a:bodyPr wrap="square" lIns="0" tIns="0" rIns="0" bIns="0" rtlCol="0" anchor="ctr"/>
+          <a:lstStyle/>
+          <a:p>
+            <a:pPr indent="0" marL="0">
+              <a:lnSpc>
+                <a:spcPct val="115000"/>
+              </a:lnSpc>
+              <a:buNone/>
+            </a:pPr>
+            <a:r>
+              <a:rPr lang="en-US" sz="1300" dirty="0">
+                <a:solidFill>
+                  <a:srgbClr val="E4E9EF"/>
+                </a:solidFill>
+                <a:latin typeface="Calibri" pitchFamily="34" charset="0"/>
+                <a:ea typeface="Calibri" pitchFamily="34" charset="-122"/>
+                <a:cs typeface="Calibri" pitchFamily="34" charset="-120"/>
+              </a:rPr>
+              <a:t>Buyers get the places plus a ready-made day-by-day plan from the trip planner — not just a list of pins.</a:t>
+            </a:r>
+            <a:endParaRPr lang="en-US" sz="1300" dirty="0"/>
+          </a:p>
+        </p:txBody>
+      </p:sp>
+      <p:sp>
+        <p:nvSpPr>
+          <p:cNvPr id="14" name="Shape 12"/>
+          <p:cNvSpPr/>
+          <p:nvPr/>
+        </p:nvSpPr>
+        <p:spPr>
+          <a:xfrm>
+            <a:off x="8321040" y="2880360"/>
+            <a:ext cx="3611880" cy="3246120"/>
+          </a:xfrm>
+          <a:prstGeom prst="rect">
+            <a:avLst/>
+          </a:prstGeom>
+          <a:solidFill>
+            <a:srgbClr val="14213D"/>
+          </a:solidFill>
+          <a:ln/>
+        </p:spPr>
+      </p:sp>
+      <p:sp>
+        <p:nvSpPr>
+          <p:cNvPr id="15" name="Text 13"/>
+          <p:cNvSpPr/>
+          <p:nvPr/>
+        </p:nvSpPr>
+        <p:spPr>
+          <a:xfrm>
+            <a:off x="8549640" y="3063240"/>
+            <a:ext cx="822960" cy="640080"/>
+          </a:xfrm>
+          <a:prstGeom prst="rect">
+            <a:avLst/>
+          </a:prstGeom>
+          <a:noFill/>
+          <a:ln/>
+        </p:spPr>
+        <p:txBody>
+          <a:bodyPr wrap="square" lIns="0" tIns="0" rIns="0" bIns="0" rtlCol="0" anchor="ctr"/>
+          <a:lstStyle/>
+          <a:p>
+            <a:pPr indent="0" marL="0">
+              <a:buNone/>
+            </a:pPr>
+            <a:r>
+              <a:rPr lang="en-US" sz="2800" dirty="0">
+                <a:solidFill>
+                  <a:srgbClr val="000000"/>
+                </a:solidFill>
+              </a:rPr>
+              <a:t>🔁</a:t>
+            </a:r>
+            <a:endParaRPr lang="en-US" sz="2800" dirty="0"/>
+          </a:p>
+        </p:txBody>
+      </p:sp>
+      <p:sp>
+        <p:nvSpPr>
+          <p:cNvPr id="16" name="Text 14"/>
+          <p:cNvSpPr/>
+          <p:nvPr/>
+        </p:nvSpPr>
+        <p:spPr>
+          <a:xfrm>
+            <a:off x="8549640" y="3703320"/>
+            <a:ext cx="3154680" cy="502920"/>
+          </a:xfrm>
+          <a:prstGeom prst="rect">
+            <a:avLst/>
+          </a:prstGeom>
+          <a:noFill/>
+          <a:ln/>
+        </p:spPr>
+        <p:txBody>
+          <a:bodyPr wrap="square" lIns="0" tIns="0" rIns="0" bIns="0" rtlCol="0" anchor="ctr"/>
+          <a:lstStyle/>
+          <a:p>
+            <a:pPr indent="0" marL="0">
+              <a:buNone/>
+            </a:pPr>
+            <a:r>
+              <a:rPr lang="en-US" sz="1600" b="1" dirty="0">
+                <a:solidFill>
+                  <a:srgbClr val="FFDE59"/>
+                </a:solidFill>
+                <a:latin typeface="Trebuchet MS" pitchFamily="34" charset="0"/>
+                <a:ea typeface="Trebuchet MS" pitchFamily="34" charset="-122"/>
+                <a:cs typeface="Trebuchet MS" pitchFamily="34" charset="-120"/>
+              </a:rPr>
+              <a:t>Built on what exists</a:t>
+            </a:r>
+            <a:endParaRPr lang="en-US" sz="1600" dirty="0"/>
+          </a:p>
+        </p:txBody>
+      </p:sp>
+      <p:sp>
+        <p:nvSpPr>
+          <p:cNvPr id="17" name="Text 15"/>
+          <p:cNvSpPr/>
+          <p:nvPr/>
+        </p:nvSpPr>
+        <p:spPr>
+          <a:xfrm>
+            <a:off x="8549640" y="4251960"/>
+            <a:ext cx="3154680" cy="1737360"/>
+          </a:xfrm>
+          <a:prstGeom prst="rect">
+            <a:avLst/>
+          </a:prstGeom>
+          <a:noFill/>
+          <a:ln/>
+        </p:spPr>
+        <p:txBody>
+          <a:bodyPr wrap="square" lIns="0" tIns="0" rIns="0" bIns="0" rtlCol="0" anchor="ctr"/>
+          <a:lstStyle/>
+          <a:p>
+            <a:pPr indent="0" marL="0">
+              <a:lnSpc>
+                <a:spcPct val="115000"/>
+              </a:lnSpc>
+              <a:buNone/>
+            </a:pPr>
+            <a:r>
+              <a:rPr lang="en-US" sz="1300" dirty="0">
+                <a:solidFill>
+                  <a:srgbClr val="E4E9EF"/>
+                </a:solidFill>
+                <a:latin typeface="Calibri" pitchFamily="34" charset="0"/>
+                <a:ea typeface="Calibri" pitchFamily="34" charset="-122"/>
+                <a:cs typeface="Calibri" pitchFamily="34" charset="-120"/>
+              </a:rPr>
+              <a:t>The export/import and trip-planner features already do most of the work — this is mainly a packaging + marketplace layer on top.</a:t>
+            </a:r>
+            <a:endParaRPr lang="en-US" sz="1300" dirty="0"/>
+          </a:p>
+        </p:txBody>
+      </p:sp>
+      <p:sp>
+        <p:nvSpPr>
+          <p:cNvPr id="18" name="Text 16"/>
+          <p:cNvSpPr/>
+          <p:nvPr/>
+        </p:nvSpPr>
+        <p:spPr>
+          <a:xfrm>
+            <a:off x="548640" y="6263640"/>
+            <a:ext cx="11064240" cy="457200"/>
+          </a:xfrm>
+          <a:prstGeom prst="rect">
+            <a:avLst/>
+          </a:prstGeom>
+          <a:noFill/>
+          <a:ln/>
+        </p:spPr>
+        <p:txBody>
+          <a:bodyPr wrap="square" lIns="0" tIns="0" rIns="0" bIns="0" rtlCol="0" anchor="ctr"/>
+          <a:lstStyle/>
+          <a:p>
+            <a:pPr indent="0" marL="0">
+              <a:buNone/>
+            </a:pPr>
+            <a:r>
+              <a:rPr lang="en-US" sz="1300" i="1" dirty="0">
+                <a:solidFill>
+                  <a:srgbClr val="5A6B7A"/>
+                </a:solidFill>
+                <a:latin typeface="Calibri" pitchFamily="34" charset="0"/>
+                <a:ea typeface="Calibri" pitchFamily="34" charset="-122"/>
+                <a:cs typeface="Calibri" pitchFamily="34" charset="-120"/>
+              </a:rPr>
+              <a:t>Still an open question: how to keep “no account needed” for browsing while supporting payments and creator profiles for sellers.</a:t>
+            </a:r>
+            <a:endParaRPr lang="en-US" sz="1300" dirty="0"/>
+          </a:p>
+        </p:txBody>
+      </p:sp>
+    </p:spTree>
+  </p:cSld>
+  <p:clrMapOvr>
+    <a:masterClrMapping/>
+  </p:clrMapOvr>
+</p:sld>
+</file>
+
+<file path=ppt/slides/slide11.xml><?xml version="1.0" encoding="utf-8"?>
+<p:sld xmlns:a="http://schemas.openxmlformats.org/drawingml/2006/main" xmlns:r="http://schemas.openxmlformats.org/officeDocument/2006/relationships" xmlns:p="http://schemas.openxmlformats.org/presentationml/2006/main">
+  <p:cSld name="Slide 11">
+    <p:bg>
+      <p:bgPr>
+        <a:solidFill>
           <a:srgbClr val="14213D"/>
         </a:solidFill>
       </p:bgPr>
@@ -1936,7 +2647,7 @@
         <p:spPr>
           <a:xfrm>
             <a:off x="822960" y="914400"/>
-            <a:ext cx="10058400" cy="914400"/>
+            <a:ext cx="7315200" cy="914400"/>
           </a:xfrm>
           <a:prstGeom prst="rect">
             <a:avLst/>
@@ -1975,7 +2686,7 @@
         <p:spPr>
           <a:xfrm>
             <a:off x="822960" y="2194560"/>
-            <a:ext cx="10058400" cy="2926080"/>
+            <a:ext cx="7315200" cy="2926080"/>
           </a:xfrm>
           <a:prstGeom prst="rect">
             <a:avLst/>
@@ -2079,7 +2790,136 @@
       </p:sp>
       <p:sp>
         <p:nvSpPr>
-          <p:cNvPr id="5" name="Text 3"/>
+          <p:cNvPr id="5" name="Shape 3"/>
+          <p:cNvSpPr/>
+          <p:nvPr/>
+        </p:nvSpPr>
+        <p:spPr>
+          <a:xfrm>
+            <a:off x="8778240" y="1371600"/>
+            <a:ext cx="2743200" cy="3291840"/>
+          </a:xfrm>
+          <a:prstGeom prst="rect">
+            <a:avLst/>
+          </a:prstGeom>
+          <a:solidFill>
+            <a:srgbClr val="FFFFFF"/>
+          </a:solidFill>
+          <a:ln/>
+          <a:effectLst>
+            <a:outerShdw sx="100000" sy="100000" kx="0" ky="0" algn="bl" rotWithShape="0" blurRad="101600" dist="38100" dir="8100000">
+              <a:srgbClr val="000000">
+                <a:alpha val="30000"/>
+              </a:srgbClr>
+            </a:outerShdw>
+          </a:effectLst>
+        </p:spPr>
+      </p:sp>
+      <p:pic>
+        <p:nvPicPr>
+          <p:cNvPr id="6" name="Image 0" descr="shots/qr-code.png">    </p:cNvPr>
+          <p:cNvPicPr>
+            <a:picLocks noChangeAspect="1"/>
+          </p:cNvPicPr>
+          <p:nvPr/>
+        </p:nvPicPr>
+        <p:blipFill>
+          <a:blip r:embed="rId1"/>
+          <a:stretch>
+            <a:fillRect/>
+          </a:stretch>
+        </p:blipFill>
+        <p:spPr>
+          <a:xfrm>
+            <a:off x="9006840" y="1600200"/>
+            <a:ext cx="2286000" cy="2286000"/>
+          </a:xfrm>
+          <a:prstGeom prst="rect">
+            <a:avLst/>
+          </a:prstGeom>
+        </p:spPr>
+      </p:pic>
+      <p:sp>
+        <p:nvSpPr>
+          <p:cNvPr id="7" name="Text 4"/>
+          <p:cNvSpPr/>
+          <p:nvPr/>
+        </p:nvSpPr>
+        <p:spPr>
+          <a:xfrm>
+            <a:off x="8778240" y="3931920"/>
+            <a:ext cx="2743200" cy="365760"/>
+          </a:xfrm>
+          <a:prstGeom prst="rect">
+            <a:avLst/>
+          </a:prstGeom>
+          <a:noFill/>
+          <a:ln/>
+        </p:spPr>
+        <p:txBody>
+          <a:bodyPr wrap="square" lIns="0" tIns="0" rIns="0" bIns="0" rtlCol="0" anchor="ctr"/>
+          <a:lstStyle/>
+          <a:p>
+            <a:pPr algn="ctr" indent="0" marL="0">
+              <a:buNone/>
+            </a:pPr>
+            <a:r>
+              <a:rPr lang="en-US" sz="1300" b="1" dirty="0">
+                <a:solidFill>
+                  <a:srgbClr val="14213D"/>
+                </a:solidFill>
+                <a:latin typeface="Trebuchet MS" pitchFamily="34" charset="0"/>
+                <a:ea typeface="Trebuchet MS" pitchFamily="34" charset="-122"/>
+                <a:cs typeface="Trebuchet MS" pitchFamily="34" charset="-120"/>
+              </a:rPr>
+              <a:t>Scan to open MapFolio</a:t>
+            </a:r>
+            <a:endParaRPr lang="en-US" sz="1300" dirty="0"/>
+          </a:p>
+        </p:txBody>
+      </p:sp>
+      <p:sp>
+        <p:nvSpPr>
+          <p:cNvPr id="8" name="Text 5"/>
+          <p:cNvSpPr/>
+          <p:nvPr/>
+        </p:nvSpPr>
+        <p:spPr>
+          <a:xfrm>
+            <a:off x="8778240" y="4251960"/>
+            <a:ext cx="2743200" cy="320040"/>
+          </a:xfrm>
+          <a:prstGeom prst="rect">
+            <a:avLst/>
+          </a:prstGeom>
+          <a:noFill/>
+          <a:ln/>
+        </p:spPr>
+        <p:txBody>
+          <a:bodyPr wrap="square" lIns="0" tIns="0" rIns="0" bIns="0" rtlCol="0" anchor="ctr"/>
+          <a:lstStyle/>
+          <a:p>
+            <a:pPr algn="ctr" indent="0" marL="0">
+              <a:buNone/>
+            </a:pPr>
+            <a:r>
+              <a:rPr lang="en-US" sz="1100" dirty="0">
+                <a:solidFill>
+                  <a:srgbClr val="5A6B7A"/>
+                </a:solidFill>
+                <a:latin typeface="Calibri" pitchFamily="34" charset="0"/>
+                <a:ea typeface="Calibri" pitchFamily="34" charset="-122"/>
+                <a:cs typeface="Calibri" pitchFamily="34" charset="-120"/>
+              </a:rPr>
+              <a:t>my-mapfolio.netlify.app</a:t>
+            </a:r>
+            <a:endParaRPr lang="en-US" sz="1100" dirty="0"/>
+          </a:p>
+        </p:txBody>
+      </p:sp>
+      <p:sp>
+        <p:nvSpPr>
+          <p:cNvPr id="9" name="Text 6"/>
           <p:cNvSpPr/>
           <p:nvPr/>
         </p:nvSpPr>
@@ -5744,24 +6584,24 @@
         </p:nvSpPr>
         <p:spPr>
           <a:xfrm>
-            <a:off x="548640" y="457200"/>
-            <a:ext cx="10972800" cy="731520"/>
-          </a:xfrm>
-          <a:prstGeom prst="rect">
-            <a:avLst/>
-          </a:prstGeom>
-          <a:noFill/>
-          <a:ln/>
-        </p:spPr>
-        <p:txBody>
-          <a:bodyPr wrap="square" lIns="0" tIns="0" rIns="0" bIns="0" rtlCol="0" anchor="ctr"/>
-          <a:lstStyle/>
-          <a:p>
-            <a:pPr indent="0" marL="0">
-              <a:buNone/>
-            </a:pPr>
-            <a:r>
-              <a:rPr lang="en-US" sz="3200" b="1" dirty="0">
+            <a:off x="548640" y="365760"/>
+            <a:ext cx="10972800" cy="640080"/>
+          </a:xfrm>
+          <a:prstGeom prst="rect">
+            <a:avLst/>
+          </a:prstGeom>
+          <a:noFill/>
+          <a:ln/>
+        </p:spPr>
+        <p:txBody>
+          <a:bodyPr wrap="square" lIns="0" tIns="0" rIns="0" bIns="0" rtlCol="0" anchor="ctr"/>
+          <a:lstStyle/>
+          <a:p>
+            <a:pPr indent="0" marL="0">
+              <a:buNone/>
+            </a:pPr>
+            <a:r>
+              <a:rPr lang="en-US" sz="3000" b="1" dirty="0">
                 <a:solidFill>
                   <a:srgbClr val="14213D"/>
                 </a:solidFill>
@@ -5771,7 +6611,7 @@
               </a:rPr>
               <a:t>Questions people ask me</a:t>
             </a:r>
-            <a:endParaRPr lang="en-US" sz="3200" dirty="0"/>
+            <a:endParaRPr lang="en-US" sz="3000" dirty="0"/>
           </a:p>
         </p:txBody>
       </p:sp>
@@ -5783,8 +6623,8 @@
         </p:nvSpPr>
         <p:spPr>
           <a:xfrm>
-            <a:off x="548640" y="1554480"/>
-            <a:ext cx="11064240" cy="1417320"/>
+            <a:off x="548640" y="1188720"/>
+            <a:ext cx="11064240" cy="1188720"/>
           </a:xfrm>
           <a:prstGeom prst="rect">
             <a:avLst/>
@@ -5803,24 +6643,24 @@
         </p:nvSpPr>
         <p:spPr>
           <a:xfrm>
-            <a:off x="822960" y="1719072"/>
-            <a:ext cx="10515600" cy="457200"/>
-          </a:xfrm>
-          <a:prstGeom prst="rect">
-            <a:avLst/>
-          </a:prstGeom>
-          <a:noFill/>
-          <a:ln/>
-        </p:spPr>
-        <p:txBody>
-          <a:bodyPr wrap="square" lIns="0" tIns="0" rIns="0" bIns="0" rtlCol="0" anchor="ctr"/>
-          <a:lstStyle/>
-          <a:p>
-            <a:pPr indent="0" marL="0">
-              <a:buNone/>
-            </a:pPr>
-            <a:r>
-              <a:rPr lang="en-US" sz="1600" b="1" dirty="0">
+            <a:off x="822960" y="1325880"/>
+            <a:ext cx="10515600" cy="411480"/>
+          </a:xfrm>
+          <a:prstGeom prst="rect">
+            <a:avLst/>
+          </a:prstGeom>
+          <a:noFill/>
+          <a:ln/>
+        </p:spPr>
+        <p:txBody>
+          <a:bodyPr wrap="square" lIns="0" tIns="0" rIns="0" bIns="0" rtlCol="0" anchor="ctr"/>
+          <a:lstStyle/>
+          <a:p>
+            <a:pPr indent="0" marL="0">
+              <a:buNone/>
+            </a:pPr>
+            <a:r>
+              <a:rPr lang="en-US" sz="1500" b="1" dirty="0">
                 <a:solidFill>
                   <a:srgbClr val="1C7293"/>
                 </a:solidFill>
@@ -5830,7 +6670,7 @@
               </a:rPr>
               <a:t>“What's the value beyond just tracking been-to / want-to-go?”</a:t>
             </a:r>
-            <a:endParaRPr lang="en-US" sz="1600" dirty="0"/>
+            <a:endParaRPr lang="en-US" sz="1500" dirty="0"/>
           </a:p>
         </p:txBody>
       </p:sp>
@@ -5842,8 +6682,8 @@
         </p:nvSpPr>
         <p:spPr>
           <a:xfrm>
-            <a:off x="822960" y="2176272"/>
-            <a:ext cx="10515600" cy="731520"/>
+            <a:off x="822960" y="1737360"/>
+            <a:ext cx="10515600" cy="594360"/>
           </a:xfrm>
           <a:prstGeom prst="rect">
             <a:avLst/>
@@ -5857,12 +6697,12 @@
           <a:p>
             <a:pPr indent="0" marL="0">
               <a:lnSpc>
-                <a:spcPct val="110000"/>
+                <a:spcPct val="105000"/>
               </a:lnSpc>
               <a:buNone/>
             </a:pPr>
             <a:r>
-              <a:rPr lang="en-US" sz="1400" dirty="0">
+              <a:rPr lang="en-US" sz="1300" dirty="0">
                 <a:solidFill>
                   <a:srgbClr val="1E1E1E"/>
                 </a:solidFill>
@@ -5872,7 +6712,7 @@
               </a:rPr>
               <a:t>Your own categories + color-coded statuses across all saved places, a trip planner that builds itineraries from a folder, and full ownership/portability of your data — none of which Google Maps offers.</a:t>
             </a:r>
-            <a:endParaRPr lang="en-US" sz="1400" dirty="0"/>
+            <a:endParaRPr lang="en-US" sz="1300" dirty="0"/>
           </a:p>
         </p:txBody>
       </p:sp>
@@ -5884,8 +6724,8 @@
         </p:nvSpPr>
         <p:spPr>
           <a:xfrm>
-            <a:off x="548640" y="3200400"/>
-            <a:ext cx="11064240" cy="1417320"/>
+            <a:off x="548640" y="2514600"/>
+            <a:ext cx="11064240" cy="1188720"/>
           </a:xfrm>
           <a:prstGeom prst="rect">
             <a:avLst/>
@@ -5904,24 +6744,24 @@
         </p:nvSpPr>
         <p:spPr>
           <a:xfrm>
-            <a:off x="822960" y="3364992"/>
-            <a:ext cx="10515600" cy="457200"/>
-          </a:xfrm>
-          <a:prstGeom prst="rect">
-            <a:avLst/>
-          </a:prstGeom>
-          <a:noFill/>
-          <a:ln/>
-        </p:spPr>
-        <p:txBody>
-          <a:bodyPr wrap="square" lIns="0" tIns="0" rIns="0" bIns="0" rtlCol="0" anchor="ctr"/>
-          <a:lstStyle/>
-          <a:p>
-            <a:pPr indent="0" marL="0">
-              <a:buNone/>
-            </a:pPr>
-            <a:r>
-              <a:rPr lang="en-US" sz="1600" b="1" dirty="0">
+            <a:off x="822960" y="2651760"/>
+            <a:ext cx="10515600" cy="411480"/>
+          </a:xfrm>
+          <a:prstGeom prst="rect">
+            <a:avLst/>
+          </a:prstGeom>
+          <a:noFill/>
+          <a:ln/>
+        </p:spPr>
+        <p:txBody>
+          <a:bodyPr wrap="square" lIns="0" tIns="0" rIns="0" bIns="0" rtlCol="0" anchor="ctr"/>
+          <a:lstStyle/>
+          <a:p>
+            <a:pPr indent="0" marL="0">
+              <a:buNone/>
+            </a:pPr>
+            <a:r>
+              <a:rPr lang="en-US" sz="1500" b="1" dirty="0">
                 <a:solidFill>
                   <a:srgbClr val="1C7293"/>
                 </a:solidFill>
@@ -5931,7 +6771,7 @@
               </a:rPr>
               <a:t>“Can I import these places back into Google Maps?”</a:t>
             </a:r>
-            <a:endParaRPr lang="en-US" sz="1600" dirty="0"/>
+            <a:endParaRPr lang="en-US" sz="1500" dirty="0"/>
           </a:p>
         </p:txBody>
       </p:sp>
@@ -5943,8 +6783,8 @@
         </p:nvSpPr>
         <p:spPr>
           <a:xfrm>
-            <a:off x="822960" y="3822192"/>
-            <a:ext cx="10515600" cy="731520"/>
+            <a:off x="822960" y="3063240"/>
+            <a:ext cx="10515600" cy="594360"/>
           </a:xfrm>
           <a:prstGeom prst="rect">
             <a:avLst/>
@@ -5958,12 +6798,12 @@
           <a:p>
             <a:pPr indent="0" marL="0">
               <a:lnSpc>
-                <a:spcPct val="110000"/>
+                <a:spcPct val="105000"/>
               </a:lnSpc>
               <a:buNone/>
             </a:pPr>
             <a:r>
-              <a:rPr lang="en-US" sz="1400" dirty="0">
+              <a:rPr lang="en-US" sz="1300" dirty="0">
                 <a:solidFill>
                   <a:srgbClr val="1E1E1E"/>
                 </a:solidFill>
@@ -5973,7 +6813,7 @@
               </a:rPr>
               <a:t>Not yet — exports are MapFolio's own format today, for backup and sharing between MapFolio users. Two-way sync with Google Maps (KML export) is on the wish list.</a:t>
             </a:r>
-            <a:endParaRPr lang="en-US" sz="1400" dirty="0"/>
+            <a:endParaRPr lang="en-US" sz="1300" dirty="0"/>
           </a:p>
         </p:txBody>
       </p:sp>
@@ -5985,8 +6825,8 @@
         </p:nvSpPr>
         <p:spPr>
           <a:xfrm>
-            <a:off x="548640" y="4846320"/>
-            <a:ext cx="11064240" cy="1417320"/>
+            <a:off x="548640" y="3840480"/>
+            <a:ext cx="11064240" cy="1188720"/>
           </a:xfrm>
           <a:prstGeom prst="rect">
             <a:avLst/>
@@ -6005,24 +6845,24 @@
         </p:nvSpPr>
         <p:spPr>
           <a:xfrm>
-            <a:off x="822960" y="5010912"/>
-            <a:ext cx="10515600" cy="457200"/>
-          </a:xfrm>
-          <a:prstGeom prst="rect">
-            <a:avLst/>
-          </a:prstGeom>
-          <a:noFill/>
-          <a:ln/>
-        </p:spPr>
-        <p:txBody>
-          <a:bodyPr wrap="square" lIns="0" tIns="0" rIns="0" bIns="0" rtlCol="0" anchor="ctr"/>
-          <a:lstStyle/>
-          <a:p>
-            <a:pPr indent="0" marL="0">
-              <a:buNone/>
-            </a:pPr>
-            <a:r>
-              <a:rPr lang="en-US" sz="1600" b="1" dirty="0">
+            <a:off x="822960" y="3977640"/>
+            <a:ext cx="10515600" cy="411480"/>
+          </a:xfrm>
+          <a:prstGeom prst="rect">
+            <a:avLst/>
+          </a:prstGeom>
+          <a:noFill/>
+          <a:ln/>
+        </p:spPr>
+        <p:txBody>
+          <a:bodyPr wrap="square" lIns="0" tIns="0" rIns="0" bIns="0" rtlCol="0" anchor="ctr"/>
+          <a:lstStyle/>
+          <a:p>
+            <a:pPr indent="0" marL="0">
+              <a:buNone/>
+            </a:pPr>
+            <a:r>
+              <a:rPr lang="en-US" sz="1500" b="1" dirty="0">
                 <a:solidFill>
                   <a:srgbClr val="1C7293"/>
                 </a:solidFill>
@@ -6032,7 +6872,7 @@
               </a:rPr>
               <a:t>“Is this connected to Booking.com?”</a:t>
             </a:r>
-            <a:endParaRPr lang="en-US" sz="1600" dirty="0"/>
+            <a:endParaRPr lang="en-US" sz="1500" dirty="0"/>
           </a:p>
         </p:txBody>
       </p:sp>
@@ -6044,8 +6884,8 @@
         </p:nvSpPr>
         <p:spPr>
           <a:xfrm>
-            <a:off x="822960" y="5468112"/>
-            <a:ext cx="10515600" cy="731520"/>
+            <a:off x="822960" y="4389120"/>
+            <a:ext cx="10515600" cy="594360"/>
           </a:xfrm>
           <a:prstGeom prst="rect">
             <a:avLst/>
@@ -6059,12 +6899,12 @@
           <a:p>
             <a:pPr indent="0" marL="0">
               <a:lnSpc>
-                <a:spcPct val="110000"/>
+                <a:spcPct val="105000"/>
               </a:lnSpc>
               <a:buNone/>
             </a:pPr>
             <a:r>
-              <a:rPr lang="en-US" sz="1400" dirty="0">
+              <a:rPr lang="en-US" sz="1300" dirty="0">
                 <a:solidFill>
                   <a:srgbClr val="1E1E1E"/>
                 </a:solidFill>
@@ -6072,9 +6912,110 @@
                 <a:ea typeface="Calibri" pitchFamily="34" charset="-122"/>
                 <a:cs typeface="Calibri" pitchFamily="34" charset="-120"/>
               </a:rPr>
-              <a:t>No. No bookings, no accounts, no external services of any kind. It's purely a personal map and trip-planning tool.</a:t>
-            </a:r>
-            <a:endParaRPr lang="en-US" sz="1400" dirty="0"/>
+              <a:t>Not today — right now it's purely a personal map and trip-planning tool, no external services. But it's a natural future direction: affiliate links to Booking.com, TripAdvisor, etc. for the places in your collection.</a:t>
+            </a:r>
+            <a:endParaRPr lang="en-US" sz="1300" dirty="0"/>
+          </a:p>
+        </p:txBody>
+      </p:sp>
+      <p:sp>
+        <p:nvSpPr>
+          <p:cNvPr id="12" name="Shape 10"/>
+          <p:cNvSpPr/>
+          <p:nvPr/>
+        </p:nvSpPr>
+        <p:spPr>
+          <a:xfrm>
+            <a:off x="548640" y="5166360"/>
+            <a:ext cx="11064240" cy="1371600"/>
+          </a:xfrm>
+          <a:prstGeom prst="rect">
+            <a:avLst/>
+          </a:prstGeom>
+          <a:solidFill>
+            <a:srgbClr val="F4F6F8"/>
+          </a:solidFill>
+          <a:ln/>
+        </p:spPr>
+      </p:sp>
+      <p:sp>
+        <p:nvSpPr>
+          <p:cNvPr id="13" name="Text 11"/>
+          <p:cNvSpPr/>
+          <p:nvPr/>
+        </p:nvSpPr>
+        <p:spPr>
+          <a:xfrm>
+            <a:off x="822960" y="5303520"/>
+            <a:ext cx="10515600" cy="411480"/>
+          </a:xfrm>
+          <a:prstGeom prst="rect">
+            <a:avLst/>
+          </a:prstGeom>
+          <a:noFill/>
+          <a:ln/>
+        </p:spPr>
+        <p:txBody>
+          <a:bodyPr wrap="square" lIns="0" tIns="0" rIns="0" bIns="0" rtlCol="0" anchor="ctr"/>
+          <a:lstStyle/>
+          <a:p>
+            <a:pPr indent="0" marL="0">
+              <a:buNone/>
+            </a:pPr>
+            <a:r>
+              <a:rPr lang="en-US" sz="1500" b="1" dirty="0">
+                <a:solidFill>
+                  <a:srgbClr val="1C7293"/>
+                </a:solidFill>
+                <a:latin typeface="Trebuchet MS" pitchFamily="34" charset="0"/>
+                <a:ea typeface="Trebuchet MS" pitchFamily="34" charset="-122"/>
+                <a:cs typeface="Trebuchet MS" pitchFamily="34" charset="-120"/>
+              </a:rPr>
+              <a:t>“What if a shared folder has a place I've already visited?”</a:t>
+            </a:r>
+            <a:endParaRPr lang="en-US" sz="1500" dirty="0"/>
+          </a:p>
+        </p:txBody>
+      </p:sp>
+      <p:sp>
+        <p:nvSpPr>
+          <p:cNvPr id="14" name="Text 12"/>
+          <p:cNvSpPr/>
+          <p:nvPr/>
+        </p:nvSpPr>
+        <p:spPr>
+          <a:xfrm>
+            <a:off x="822960" y="5715000"/>
+            <a:ext cx="10515600" cy="777240"/>
+          </a:xfrm>
+          <a:prstGeom prst="rect">
+            <a:avLst/>
+          </a:prstGeom>
+          <a:noFill/>
+          <a:ln/>
+        </p:spPr>
+        <p:txBody>
+          <a:bodyPr wrap="square" lIns="0" tIns="0" rIns="0" bIns="0" rtlCol="0" anchor="ctr"/>
+          <a:lstStyle/>
+          <a:p>
+            <a:pPr indent="0" marL="0">
+              <a:lnSpc>
+                <a:spcPct val="105000"/>
+              </a:lnSpc>
+              <a:buNone/>
+            </a:pPr>
+            <a:r>
+              <a:rPr lang="en-US" sz="1300" dirty="0">
+                <a:solidFill>
+                  <a:srgbClr val="1E1E1E"/>
+                </a:solidFill>
+                <a:latin typeface="Calibri" pitchFamily="34" charset="0"/>
+                <a:ea typeface="Calibri" pitchFamily="34" charset="-122"/>
+                <a:cs typeface="Calibri" pitchFamily="34" charset="-120"/>
+              </a:rPr>
+              <a:t>Your existing status always wins — if MapFolio recognizes the place (same link or name), the imported copy is skipped so your status (e.g. "Loved It") isn't overwritten. It just won't show up in the new shared folder.</a:t>
+            </a:r>
+            <a:endParaRPr lang="en-US" sz="1300" dirty="0"/>
           </a:p>
         </p:txBody>
       </p:sp>

</xml_diff>